<commit_message>
Move updated pitch deck into docs/
Co-Authored-By: Claude Opus 5.5 <noreply@anthropic.com>
</commit_message>
<xml_diff>
--- a/docs/pitch-deck.pptx
+++ b/docs/pitch-deck.pptx
@@ -1652,22 +1652,14 @@
               <a:buNone/>
             </a:pPr>
             <a:r>
-              <a:rPr lang="en-GB" sz="3200" b="1" dirty="0">
+              <a:rPr sz="3200" b="1">
                 <a:solidFill>
                   <a:schemeClr val="bg1"/>
                 </a:solidFill>
               </a:rPr>
-              <a:t>You need the right help.</a:t>
-            </a:r>
-            <a:r>
-              <a:rPr sz="3200" b="1" dirty="0">
-                <a:solidFill>
-                  <a:schemeClr val="bg1"/>
-                </a:solidFill>
-              </a:rPr>
-              <a:t> Where do you turn?</a:t>
-            </a:r>
-            <a:endParaRPr sz="3200" dirty="0"/>
+              <a:t>It's 2 AM. You need help. Where do you turn?</a:t>
+            </a:r>
+            <a:endParaRPr sz="3200"/>
           </a:p>
         </p:txBody>
       </p:sp>
@@ -1810,50 +1802,14 @@
               <a:buNone/>
             </a:pPr>
             <a:r>
-              <a:rPr sz="2500" b="1" i="1" dirty="0">
+              <a:rPr sz="2500" b="1" i="1">
                 <a:solidFill>
                   <a:schemeClr val="tx1"/>
                 </a:solidFill>
               </a:rPr>
-              <a:t>“</a:t>
-            </a:r>
-            <a:r>
-              <a:rPr lang="de-DE" sz="2500" b="1" i="1" dirty="0"/>
-              <a:t>My </a:t>
-            </a:r>
-            <a:r>
-              <a:rPr lang="de-DE" sz="2500" b="1" i="1" dirty="0" err="1"/>
-              <a:t>landlord</a:t>
-            </a:r>
-            <a:r>
-              <a:rPr lang="de-DE" sz="2500" b="1" i="1" dirty="0"/>
-              <a:t> just </a:t>
-            </a:r>
-            <a:r>
-              <a:rPr lang="de-DE" sz="2500" b="1" i="1" dirty="0" err="1"/>
-              <a:t>kicked</a:t>
-            </a:r>
-            <a:r>
-              <a:rPr lang="de-DE" sz="2500" b="1" i="1" dirty="0"/>
-              <a:t> </a:t>
-            </a:r>
-            <a:r>
-              <a:rPr lang="de-DE" sz="2500" b="1" i="1" dirty="0" err="1"/>
-              <a:t>me</a:t>
-            </a:r>
-            <a:r>
-              <a:rPr lang="de-DE" sz="2500" b="1" i="1" dirty="0"/>
-              <a:t> out. What do I do now?</a:t>
-            </a:r>
-            <a:r>
-              <a:rPr sz="2500" b="1" i="1" dirty="0">
-                <a:solidFill>
-                  <a:schemeClr val="tx1"/>
-                </a:solidFill>
-              </a:rPr>
-              <a:t>”</a:t>
-            </a:r>
-            <a:endParaRPr sz="2500" dirty="0"/>
+              <a:t>“I just found out I'm pregnant. Who can I talk to?”</a:t>
+            </a:r>
+            <a:endParaRPr sz="2500"/>
           </a:p>
         </p:txBody>
       </p:sp>

</xml_diff>